<commit_message>
Remove workstream labels from Review 2 and tidy the forecasting slide
</commit_message>
<xml_diff>
--- a/presentations/GridWeave_Review1.pptx
+++ b/presentations/GridWeave_Review1.pptx
@@ -18160,19 +18160,19 @@
           </p:nvPr>
         </p:nvGraphicFramePr>
         <p:xfrm>
-          <a:off x="548640" y="2926080"/>
-          <a:ext cx="6858000" cy="914400"/>
+          <a:off x="548640" y="2880360"/>
+          <a:ext cx="6903720" cy="914400"/>
         </p:xfrm>
         <a:graphic>
           <a:graphicData uri="http://schemas.openxmlformats.org/drawingml/2006/table">
             <a:tbl>
               <a:tblPr/>
               <a:tblGrid>
-                <a:gridCol w="1737360"/>
-                <a:gridCol w="2514600"/>
-                <a:gridCol w="2606040"/>
+                <a:gridCol w="1691640"/>
+                <a:gridCol w="2560320"/>
+                <a:gridCol w="2651760"/>
               </a:tblGrid>
-              <a:tr h="548640">
+              <a:tr h="512064">
                 <a:tc>
                   <a:txBody>
                     <a:bodyPr/>
@@ -18182,7 +18182,7 @@
                         <a:buNone/>
                       </a:pPr>
                       <a:r>
-                        <a:rPr lang="en-US" sz="1350" b="1" dirty="0">
+                        <a:rPr lang="en-US" sz="1300" b="1" dirty="0">
                           <a:solidFill>
                             <a:srgbClr val="FFFFFF"/>
                           </a:solidFill>
@@ -18192,7 +18192,7 @@
                         </a:rPr>
                         <a:t>Input</a:t>
                       </a:r>
-                      <a:endParaRPr lang="en-US" sz="1350" dirty="0">
+                      <a:endParaRPr lang="en-US" sz="1300" dirty="0">
                         <a:latin typeface="Calibri" charset="0"/>
                         <a:ea typeface="Calibri" charset="0"/>
                         <a:cs typeface="Calibri" charset="0"/>
@@ -18250,7 +18250,7 @@
                         <a:buNone/>
                       </a:pPr>
                       <a:r>
-                        <a:rPr lang="en-US" sz="1350" b="1" dirty="0">
+                        <a:rPr lang="en-US" sz="1300" b="1" dirty="0">
                           <a:solidFill>
                             <a:srgbClr val="FFFFFF"/>
                           </a:solidFill>
@@ -18260,7 +18260,7 @@
                         </a:rPr>
                         <a:t>In plain words</a:t>
                       </a:r>
-                      <a:endParaRPr lang="en-US" sz="1350" dirty="0">
+                      <a:endParaRPr lang="en-US" sz="1300" dirty="0">
                         <a:latin typeface="Calibri" charset="0"/>
                         <a:ea typeface="Calibri" charset="0"/>
                         <a:cs typeface="Calibri" charset="0"/>
@@ -18318,7 +18318,7 @@
                         <a:buNone/>
                       </a:pPr>
                       <a:r>
-                        <a:rPr lang="en-US" sz="1350" b="1" dirty="0">
+                        <a:rPr lang="en-US" sz="1300" b="1" dirty="0">
                           <a:solidFill>
                             <a:srgbClr val="FFFFFF"/>
                           </a:solidFill>
@@ -18328,7 +18328,7 @@
                         </a:rPr>
                         <a:t>Why it helps</a:t>
                       </a:r>
-                      <a:endParaRPr lang="en-US" sz="1350" dirty="0">
+                      <a:endParaRPr lang="en-US" sz="1300" dirty="0">
                         <a:latin typeface="Calibri" charset="0"/>
                         <a:ea typeface="Calibri" charset="0"/>
                         <a:cs typeface="Calibri" charset="0"/>
@@ -18378,7 +18378,7 @@
                   </a:tcPr>
                 </a:tc>
               </a:tr>
-              <a:tr h="548640">
+              <a:tr h="512064">
                 <a:tc>
                   <a:txBody>
                     <a:bodyPr/>
@@ -18388,7 +18388,7 @@
                         <a:buNone/>
                       </a:pPr>
                       <a:r>
-                        <a:rPr lang="en-US" sz="1350" dirty="0">
+                        <a:rPr lang="en-US" sz="1300" dirty="0">
                           <a:solidFill>
                             <a:srgbClr val="1B2430"/>
                           </a:solidFill>
@@ -18398,7 +18398,7 @@
                         </a:rPr>
                         <a:t>D(t)</a:t>
                       </a:r>
-                      <a:endParaRPr lang="en-US" sz="1350" dirty="0">
+                      <a:endParaRPr lang="en-US" sz="1300" dirty="0">
                         <a:latin typeface="Calibri" charset="0"/>
                         <a:ea typeface="Calibri" charset="0"/>
                         <a:cs typeface="Calibri" charset="0"/>
@@ -18456,7 +18456,7 @@
                         <a:buNone/>
                       </a:pPr>
                       <a:r>
-                        <a:rPr lang="en-US" sz="1350" dirty="0">
+                        <a:rPr lang="en-US" sz="1300" dirty="0">
                           <a:solidFill>
                             <a:srgbClr val="1B2430"/>
                           </a:solidFill>
@@ -18466,7 +18466,7 @@
                         </a:rPr>
                         <a:t>Demand right now</a:t>
                       </a:r>
-                      <a:endParaRPr lang="en-US" sz="1350" dirty="0">
+                      <a:endParaRPr lang="en-US" sz="1300" dirty="0">
                         <a:latin typeface="Calibri" charset="0"/>
                         <a:ea typeface="Calibri" charset="0"/>
                         <a:cs typeface="Calibri" charset="0"/>
@@ -18524,7 +18524,7 @@
                         <a:buNone/>
                       </a:pPr>
                       <a:r>
-                        <a:rPr lang="en-US" sz="1350" dirty="0">
+                        <a:rPr lang="en-US" sz="1300" dirty="0">
                           <a:solidFill>
                             <a:srgbClr val="1B2430"/>
                           </a:solidFill>
@@ -18534,7 +18534,7 @@
                         </a:rPr>
                         <a:t>The best single clue to the next 15 minutes</a:t>
                       </a:r>
-                      <a:endParaRPr lang="en-US" sz="1350" dirty="0">
+                      <a:endParaRPr lang="en-US" sz="1300" dirty="0">
                         <a:latin typeface="Calibri" charset="0"/>
                         <a:ea typeface="Calibri" charset="0"/>
                         <a:cs typeface="Calibri" charset="0"/>
@@ -18584,7 +18584,7 @@
                   </a:tcPr>
                 </a:tc>
               </a:tr>
-              <a:tr h="548640">
+              <a:tr h="512064">
                 <a:tc>
                   <a:txBody>
                     <a:bodyPr/>
@@ -18594,7 +18594,7 @@
                         <a:buNone/>
                       </a:pPr>
                       <a:r>
-                        <a:rPr lang="en-US" sz="1350" dirty="0">
+                        <a:rPr lang="en-US" sz="1300" dirty="0">
                           <a:solidFill>
                             <a:srgbClr val="1B2430"/>
                           </a:solidFill>
@@ -18604,7 +18604,7 @@
                         </a:rPr>
                         <a:t>D(t−1), D(t−2)</a:t>
                       </a:r>
-                      <a:endParaRPr lang="en-US" sz="1350" dirty="0">
+                      <a:endParaRPr lang="en-US" sz="1300" dirty="0">
                         <a:latin typeface="Calibri" charset="0"/>
                         <a:ea typeface="Calibri" charset="0"/>
                         <a:cs typeface="Calibri" charset="0"/>
@@ -18662,7 +18662,7 @@
                         <a:buNone/>
                       </a:pPr>
                       <a:r>
-                        <a:rPr lang="en-US" sz="1350" dirty="0">
+                        <a:rPr lang="en-US" sz="1300" dirty="0">
                           <a:solidFill>
                             <a:srgbClr val="1B2430"/>
                           </a:solidFill>
@@ -18672,7 +18672,7 @@
                         </a:rPr>
                         <a:t>Demand 15 and 30 minutes ago</a:t>
                       </a:r>
-                      <a:endParaRPr lang="en-US" sz="1350" dirty="0">
+                      <a:endParaRPr lang="en-US" sz="1300" dirty="0">
                         <a:latin typeface="Calibri" charset="0"/>
                         <a:ea typeface="Calibri" charset="0"/>
                         <a:cs typeface="Calibri" charset="0"/>
@@ -18730,7 +18730,7 @@
                         <a:buNone/>
                       </a:pPr>
                       <a:r>
-                        <a:rPr lang="en-US" sz="1350" dirty="0">
+                        <a:rPr lang="en-US" sz="1300" dirty="0">
                           <a:solidFill>
                             <a:srgbClr val="1B2430"/>
                           </a:solidFill>
@@ -18740,7 +18740,7 @@
                         </a:rPr>
                         <a:t>Shows whether demand is rising or falling</a:t>
                       </a:r>
-                      <a:endParaRPr lang="en-US" sz="1350" dirty="0">
+                      <a:endParaRPr lang="en-US" sz="1300" dirty="0">
                         <a:latin typeface="Calibri" charset="0"/>
                         <a:ea typeface="Calibri" charset="0"/>
                         <a:cs typeface="Calibri" charset="0"/>
@@ -18790,7 +18790,7 @@
                   </a:tcPr>
                 </a:tc>
               </a:tr>
-              <a:tr h="548640">
+              <a:tr h="512064">
                 <a:tc>
                   <a:txBody>
                     <a:bodyPr/>
@@ -18800,7 +18800,7 @@
                         <a:buNone/>
                       </a:pPr>
                       <a:r>
-                        <a:rPr lang="en-US" sz="1350" dirty="0">
+                        <a:rPr lang="en-US" sz="1300" dirty="0">
                           <a:solidFill>
                             <a:srgbClr val="1B2430"/>
                           </a:solidFill>
@@ -18810,7 +18810,7 @@
                         </a:rPr>
                         <a:t>D(t−95)</a:t>
                       </a:r>
-                      <a:endParaRPr lang="en-US" sz="1350" dirty="0">
+                      <a:endParaRPr lang="en-US" sz="1300" dirty="0">
                         <a:latin typeface="Calibri" charset="0"/>
                         <a:ea typeface="Calibri" charset="0"/>
                         <a:cs typeface="Calibri" charset="0"/>
@@ -18868,7 +18868,7 @@
                         <a:buNone/>
                       </a:pPr>
                       <a:r>
-                        <a:rPr lang="en-US" sz="1350" dirty="0">
+                        <a:rPr lang="en-US" sz="1300" dirty="0">
                           <a:solidFill>
                             <a:srgbClr val="1B2430"/>
                           </a:solidFill>
@@ -18878,7 +18878,7 @@
                         </a:rPr>
                         <a:t>Demand at the same time yesterday</a:t>
                       </a:r>
-                      <a:endParaRPr lang="en-US" sz="1350" dirty="0">
+                      <a:endParaRPr lang="en-US" sz="1300" dirty="0">
                         <a:latin typeface="Calibri" charset="0"/>
                         <a:ea typeface="Calibri" charset="0"/>
                         <a:cs typeface="Calibri" charset="0"/>
@@ -18936,7 +18936,7 @@
                         <a:buNone/>
                       </a:pPr>
                       <a:r>
-                        <a:rPr lang="en-US" sz="1350" dirty="0">
+                        <a:rPr lang="en-US" sz="1300" dirty="0">
                           <a:solidFill>
                             <a:srgbClr val="1B2430"/>
                           </a:solidFill>
@@ -18946,7 +18946,7 @@
                         </a:rPr>
                         <a:t>Captures the daily routine: classes, lab hours, hostel evenings</a:t>
                       </a:r>
-                      <a:endParaRPr lang="en-US" sz="1350" dirty="0">
+                      <a:endParaRPr lang="en-US" sz="1300" dirty="0">
                         <a:latin typeface="Calibri" charset="0"/>
                         <a:ea typeface="Calibri" charset="0"/>
                         <a:cs typeface="Calibri" charset="0"/>
@@ -18996,7 +18996,7 @@
                   </a:tcPr>
                 </a:tc>
               </a:tr>
-              <a:tr h="548640">
+              <a:tr h="512064">
                 <a:tc>
                   <a:txBody>
                     <a:bodyPr/>
@@ -19006,7 +19006,7 @@
                         <a:buNone/>
                       </a:pPr>
                       <a:r>
-                        <a:rPr lang="en-US" sz="1350" dirty="0">
+                        <a:rPr lang="en-US" sz="1300" dirty="0">
                           <a:solidFill>
                             <a:srgbClr val="1B2430"/>
                           </a:solidFill>
@@ -19016,7 +19016,7 @@
                         </a:rPr>
                         <a:t>D(t−95) − D(t−96)</a:t>
                       </a:r>
-                      <a:endParaRPr lang="en-US" sz="1350" dirty="0">
+                      <a:endParaRPr lang="en-US" sz="1300" dirty="0">
                         <a:latin typeface="Calibri" charset="0"/>
                         <a:ea typeface="Calibri" charset="0"/>
                         <a:cs typeface="Calibri" charset="0"/>
@@ -19074,7 +19074,7 @@
                         <a:buNone/>
                       </a:pPr>
                       <a:r>
-                        <a:rPr lang="en-US" sz="1350" dirty="0">
+                        <a:rPr lang="en-US" sz="1300" dirty="0">
                           <a:solidFill>
                             <a:srgbClr val="1B2430"/>
                           </a:solidFill>
@@ -19084,7 +19084,7 @@
                         </a:rPr>
                         <a:t>How demand changed at this time yesterday</a:t>
                       </a:r>
-                      <a:endParaRPr lang="en-US" sz="1350" dirty="0">
+                      <a:endParaRPr lang="en-US" sz="1300" dirty="0">
                         <a:latin typeface="Calibri" charset="0"/>
                         <a:ea typeface="Calibri" charset="0"/>
                         <a:cs typeface="Calibri" charset="0"/>
@@ -19142,7 +19142,7 @@
                         <a:buNone/>
                       </a:pPr>
                       <a:r>
-                        <a:rPr lang="en-US" sz="1350" dirty="0">
+                        <a:rPr lang="en-US" sz="1300" dirty="0">
                           <a:solidFill>
                             <a:srgbClr val="1B2430"/>
                           </a:solidFill>
@@ -19152,7 +19152,7 @@
                         </a:rPr>
                         <a:t>Anticipates ramps, e.g. the 9 am jump</a:t>
                       </a:r>
-                      <a:endParaRPr lang="en-US" sz="1350" dirty="0">
+                      <a:endParaRPr lang="en-US" sz="1300" dirty="0">
                         <a:latin typeface="Calibri" charset="0"/>
                         <a:ea typeface="Calibri" charset="0"/>
                         <a:cs typeface="Calibri" charset="0"/>
@@ -19202,7 +19202,7 @@
                   </a:tcPr>
                 </a:tc>
               </a:tr>
-              <a:tr h="548640">
+              <a:tr h="512064">
                 <a:tc>
                   <a:txBody>
                     <a:bodyPr/>
@@ -19212,7 +19212,7 @@
                         <a:buNone/>
                       </a:pPr>
                       <a:r>
-                        <a:rPr lang="en-US" sz="1350" dirty="0">
+                        <a:rPr lang="en-US" sz="1300" dirty="0">
                           <a:solidFill>
                             <a:srgbClr val="1B2430"/>
                           </a:solidFill>
@@ -19222,7 +19222,7 @@
                         </a:rPr>
                         <a:t>w₀</a:t>
                       </a:r>
-                      <a:endParaRPr lang="en-US" sz="1350" dirty="0">
+                      <a:endParaRPr lang="en-US" sz="1300" dirty="0">
                         <a:latin typeface="Calibri" charset="0"/>
                         <a:ea typeface="Calibri" charset="0"/>
                         <a:cs typeface="Calibri" charset="0"/>
@@ -19280,7 +19280,7 @@
                         <a:buNone/>
                       </a:pPr>
                       <a:r>
-                        <a:rPr lang="en-US" sz="1350" dirty="0">
+                        <a:rPr lang="en-US" sz="1300" dirty="0">
                           <a:solidFill>
                             <a:srgbClr val="1B2430"/>
                           </a:solidFill>
@@ -19290,7 +19290,7 @@
                         </a:rPr>
                         <a:t>A constant</a:t>
                       </a:r>
-                      <a:endParaRPr lang="en-US" sz="1350" dirty="0">
+                      <a:endParaRPr lang="en-US" sz="1300" dirty="0">
                         <a:latin typeface="Calibri" charset="0"/>
                         <a:ea typeface="Calibri" charset="0"/>
                         <a:cs typeface="Calibri" charset="0"/>
@@ -19348,7 +19348,7 @@
                         <a:buNone/>
                       </a:pPr>
                       <a:r>
-                        <a:rPr lang="en-US" sz="1350" dirty="0">
+                        <a:rPr lang="en-US" sz="1300" dirty="0">
                           <a:solidFill>
                             <a:srgbClr val="1B2430"/>
                           </a:solidFill>
@@ -19358,7 +19358,7 @@
                         </a:rPr>
                         <a:t>The building's baseline level</a:t>
                       </a:r>
-                      <a:endParaRPr lang="en-US" sz="1350" dirty="0">
+                      <a:endParaRPr lang="en-US" sz="1300" dirty="0">
                         <a:latin typeface="Calibri" charset="0"/>
                         <a:ea typeface="Calibri" charset="0"/>
                         <a:cs typeface="Calibri" charset="0"/>

</xml_diff>